<commit_message>
Clarify the indexer as an off-chain public read service
</commit_message>
<xml_diff>
--- a/submission/MatchProof-pitch.ko-en.pptx
+++ b/submission/MatchProof-pitch.ko-en.pptx
@@ -2,23 +2,23 @@
 <file path=ppt/presentation.xml><?xml version="1.0" encoding="utf-8"?>
 <p:presentation xmlns:p="http://schemas.openxmlformats.org/presentationml/2006/main">
   <p:sldMasterIdLst>
-    <p:sldMasterId xmlns:r="http://schemas.openxmlformats.org/officeDocument/2006/relationships" id="2147483648" r:id="Re32eef7e25224e87"/>
+    <p:sldMasterId xmlns:r="http://schemas.openxmlformats.org/officeDocument/2006/relationships" id="2147483648" r:id="R08201cd95a7b46d2"/>
   </p:sldMasterIdLst>
   <p:notesMasterIdLst>
-    <p:notesMasterId xmlns:r="http://schemas.openxmlformats.org/officeDocument/2006/relationships" r:id="R635feaf4b3c543da"/>
+    <p:notesMasterId xmlns:r="http://schemas.openxmlformats.org/officeDocument/2006/relationships" r:id="R2d868304004943ca"/>
   </p:notesMasterIdLst>
   <p:sldIdLst>
-    <p:sldId xmlns:r="http://schemas.openxmlformats.org/officeDocument/2006/relationships" id="256" r:id="R199d43c8ce0046f7"/>
-    <p:sldId xmlns:r="http://schemas.openxmlformats.org/officeDocument/2006/relationships" id="257" r:id="R73b28efe9b77416d"/>
-    <p:sldId xmlns:r="http://schemas.openxmlformats.org/officeDocument/2006/relationships" id="258" r:id="R45cc55f9424b4dab"/>
-    <p:sldId xmlns:r="http://schemas.openxmlformats.org/officeDocument/2006/relationships" id="259" r:id="Ra1a06162310d4255"/>
-    <p:sldId xmlns:r="http://schemas.openxmlformats.org/officeDocument/2006/relationships" id="260" r:id="Rcfe10748b2c34932"/>
-    <p:sldId xmlns:r="http://schemas.openxmlformats.org/officeDocument/2006/relationships" id="261" r:id="Rc8814fecfada4869"/>
-    <p:sldId xmlns:r="http://schemas.openxmlformats.org/officeDocument/2006/relationships" id="262" r:id="R70d437d490fc4d23"/>
-    <p:sldId xmlns:r="http://schemas.openxmlformats.org/officeDocument/2006/relationships" id="263" r:id="R0874066e218a48f7"/>
-    <p:sldId xmlns:r="http://schemas.openxmlformats.org/officeDocument/2006/relationships" id="264" r:id="R24d380491f8f4d47"/>
-    <p:sldId xmlns:r="http://schemas.openxmlformats.org/officeDocument/2006/relationships" id="265" r:id="Raba660e7077a4a97"/>
-    <p:sldId xmlns:r="http://schemas.openxmlformats.org/officeDocument/2006/relationships" id="266" r:id="R38613ff481064377"/>
+    <p:sldId xmlns:r="http://schemas.openxmlformats.org/officeDocument/2006/relationships" id="256" r:id="R5508ccd3963e492d"/>
+    <p:sldId xmlns:r="http://schemas.openxmlformats.org/officeDocument/2006/relationships" id="257" r:id="R7a71bd11b4cf4986"/>
+    <p:sldId xmlns:r="http://schemas.openxmlformats.org/officeDocument/2006/relationships" id="258" r:id="R9032d73ec33e468d"/>
+    <p:sldId xmlns:r="http://schemas.openxmlformats.org/officeDocument/2006/relationships" id="259" r:id="R3b30dd9af2ba4c04"/>
+    <p:sldId xmlns:r="http://schemas.openxmlformats.org/officeDocument/2006/relationships" id="260" r:id="R3eb395c1f5bf4118"/>
+    <p:sldId xmlns:r="http://schemas.openxmlformats.org/officeDocument/2006/relationships" id="261" r:id="Ra85a8982a48a4304"/>
+    <p:sldId xmlns:r="http://schemas.openxmlformats.org/officeDocument/2006/relationships" id="262" r:id="R119b384cee6b4383"/>
+    <p:sldId xmlns:r="http://schemas.openxmlformats.org/officeDocument/2006/relationships" id="263" r:id="R176b0f7b063146db"/>
+    <p:sldId xmlns:r="http://schemas.openxmlformats.org/officeDocument/2006/relationships" id="264" r:id="R2c8e010ad73d4b30"/>
+    <p:sldId xmlns:r="http://schemas.openxmlformats.org/officeDocument/2006/relationships" id="265" r:id="Rad22eb091da44b96"/>
+    <p:sldId xmlns:r="http://schemas.openxmlformats.org/officeDocument/2006/relationships" id="266" r:id="R0eb8b46cf5334619"/>
   </p:sldIdLst>
   <p:sldSz cx="12192000" cy="6858000"/>
   <p:notesSz cx="6858000" cy="9144000"/>
@@ -1262,7 +1262,7 @@
           <a:lstStyle xmlns:a="http://schemas.openxmlformats.org/drawingml/2006/main"/>
           <a:p xmlns:a="http://schemas.openxmlformats.org/drawingml/2006/main">
             <a:r>
-              <a:t>인덱서는 개발 체인의 확정된 공개 상태를 조회 가능하게 제공합니다. 업체나 심사위원은 배포 주소로 같은 공개 상태를 읽습니다. 가상 접수번호와 요청의 대응은 업체의 로컬 상태에 있으므로 독립 조회에서는 공개 요청 식별값을 비교합니다. 결과를 업체 서버가 임의로 생성하지 않습니다. 요청이 만료되면 승인 이력이 있어도 UI는 기한 만료로 표시합니다. 공개 기록 자체는 남습니다. 이 그림의 첫 화살표는 데이터의 출처를 나타내며 체인이 인덱서로 특정 push API를 호출한다고 뜻하지 않습니다.</a:t>
+              <a:t>인덱서는 체인 밖에서 실행하는 조회 서버입니다. 개발 체인의 확정된 공개 상태를 따라가며 조회하기 쉽게 정리합니다. 증명을 검증하고 승인 기록을 확정하는 곳은 Midnight입니다. 업체와 심사위원은 배포 주소로 인덱서를 조회하고 공개 요청 식별값·기한·승인 기록을 읽습니다. 지갑이나 신청자 자격 파일은 필요하지 않습니다. 여기서 공개는 조회 대상이 공개 원장이라는 뜻이며, 데모 인덱서는 로컬 개발 서비스입니다.</a:t>
             </a:r>
           </a:p>
           <a:p xmlns:a="http://schemas.openxmlformats.org/drawingml/2006/main">
@@ -1272,7 +1272,7 @@
           </a:p>
           <a:p xmlns:a="http://schemas.openxmlformats.org/drawingml/2006/main">
             <a:r>
-              <a:t>The indexer exposes confirmed public chain state. The agency and judge query it by contract address. Compare public request identifiers because the agency keeps its synthetic reference mapping in local state. The agency does not manufacture the result. Expired requests appear as expired even when historical approvals remain. The first arrow describes data provenance, not a specific push API.</a:t>
+              <a:t>별도 조회는 신청자의 보관함에 의존하지 않는다는 뜻입니다. 현재 브라우저는 설정된 인덱서의 응답을 읽으며 체인 헤더와 포함 증명을 직접 검증하는 라이트 클라이언트가 아닙니다. 인덱서의 응답 정확성과 동기화 상태에 의존합니다. 인덱서의 조회 데이터가 바뀌어도 실제 체인 기록이 바뀌지는 않습니다. 가상 접수번호는 업체의 로컬 표시값이므로 같은 배포 주소와 공개 요청 식별값을 비교합니다. 기한 만료 뒤에도 공개 승인 이력은 남습니다. 첫 화살표는 데이터 출처를 나타내며 특정 push API를 뜻하지 않습니다.</a:t>
             </a:r>
           </a:p>
           <a:p xmlns:a="http://schemas.openxmlformats.org/drawingml/2006/main">
@@ -1282,12 +1282,22 @@
           </a:p>
           <a:p xmlns:a="http://schemas.openxmlformats.org/drawingml/2006/main">
             <a:r>
+              <a:t>The indexer runs off-chain and serves public state from the local development chain. Midnight validates proof-bearing transactions and records approvals. Agency and judge views read by contract address without a wallet or applicant credential. Public refers to the ledger data, not a publicly hosted endpoint. This browser trusts the configured indexer response and does not independently authenticate it using chain headers and inclusion proofs. A separate read is independent of the applicant vault, not of the indexer. Compare contract addresses and public request identifiers. Expiry retains history. The first arrow describes data provenance, not a specific push API.</a:t>
+            </a:r>
+          </a:p>
+          <a:p xmlns:a="http://schemas.openxmlformats.org/drawingml/2006/main">
+            <a:r>
+              <a:t/>
+            </a:r>
+          </a:p>
+          <a:p xmlns:a="http://schemas.openxmlformats.org/drawingml/2006/main">
+            <a:r>
               <a:t>Sources:</a:t>
             </a:r>
           </a:p>
           <a:p xmlns:a="http://schemas.openxmlformats.org/drawingml/2006/main">
             <a:r>
-              <a:t>https://github.com/team-hyunjae/MatchProof/blob/main/contracts/matchproof.compact</a:t>
+              <a:t>https://docs.midnight.network/glossary</a:t>
             </a:r>
           </a:p>
           <a:p xmlns:a="http://schemas.openxmlformats.org/drawingml/2006/main">
@@ -1297,7 +1307,7 @@
           </a:p>
           <a:p xmlns:a="http://schemas.openxmlformats.org/drawingml/2006/main">
             <a:r>
-              <a:t>https://github.com/team-hyunjae/MatchProof/blob/main/docs/matchproof-judge-guide.en.md</a:t>
+              <a:t>https://github.com/team-hyunjae/MatchProof/blob/main/infra/compose.yml</a:t>
             </a:r>
           </a:p>
         </p:txBody>
@@ -1565,7 +1575,7 @@
   </p:cSld>
   <p:clrMap bg1="lt1" tx1="dk1" bg2="lt2" tx2="dk2" accent1="accent1" accent2="accent2" accent3="accent3" accent4="accent4" accent5="accent5" accent6="accent6" hlink="hlink" folHlink="folHlink"/>
   <p:sldLayoutIdLst>
-    <p:sldLayoutId xmlns:r="http://schemas.openxmlformats.org/officeDocument/2006/relationships" id="2147483649" r:id="Re419235e44dc4515"/>
+    <p:sldLayoutId xmlns:r="http://schemas.openxmlformats.org/officeDocument/2006/relationships" id="2147483649" r:id="R446b5e8707124cc9"/>
   </p:sldLayoutIdLst>
   <p:txStyles>
     <p:titleStyle>
@@ -3908,6 +3918,7 @@
           <a:lstStyle xmlns:a="http://schemas.openxmlformats.org/drawingml/2006/main"/>
           <a:p xmlns:a="http://schemas.openxmlformats.org/drawingml/2006/main">
             <a:pPr algn="l">
+              <a:buNone/>
               <a:defRPr sz="3300" b="1">
                 <a:solidFill>
                   <a:srgbClr val="213C33"/>
@@ -3965,6 +3976,7 @@
           <a:lstStyle xmlns:a="http://schemas.openxmlformats.org/drawingml/2006/main"/>
           <a:p xmlns:a="http://schemas.openxmlformats.org/drawingml/2006/main">
             <a:pPr algn="l">
+              <a:buNone/>
               <a:defRPr sz="2325" b="0">
                 <a:solidFill>
                   <a:srgbClr val="64766C"/>
@@ -4054,6 +4066,7 @@
           <a:lstStyle xmlns:a="http://schemas.openxmlformats.org/drawingml/2006/main"/>
           <a:p xmlns:a="http://schemas.openxmlformats.org/drawingml/2006/main">
             <a:pPr algn="ctr">
+              <a:buNone/>
               <a:defRPr sz="2100" b="1">
                 <a:solidFill>
                   <a:srgbClr val="213C33"/>
@@ -4111,6 +4124,7 @@
           <a:lstStyle xmlns:a="http://schemas.openxmlformats.org/drawingml/2006/main"/>
           <a:p xmlns:a="http://schemas.openxmlformats.org/drawingml/2006/main">
             <a:pPr algn="ctr">
+              <a:buNone/>
               <a:defRPr sz="1575" b="0">
                 <a:solidFill>
                   <a:srgbClr val="64766C"/>
@@ -4200,6 +4214,7 @@
           <a:lstStyle xmlns:a="http://schemas.openxmlformats.org/drawingml/2006/main"/>
           <a:p xmlns:a="http://schemas.openxmlformats.org/drawingml/2006/main">
             <a:pPr algn="ctr">
+              <a:buNone/>
               <a:defRPr sz="2100" b="1">
                 <a:solidFill>
                   <a:srgbClr val="213C33"/>
@@ -4257,6 +4272,7 @@
           <a:lstStyle xmlns:a="http://schemas.openxmlformats.org/drawingml/2006/main"/>
           <a:p xmlns:a="http://schemas.openxmlformats.org/drawingml/2006/main">
             <a:pPr algn="ctr">
+              <a:buNone/>
               <a:defRPr sz="1575" b="0">
                 <a:solidFill>
                   <a:srgbClr val="64766C"/>
@@ -4346,6 +4362,7 @@
           <a:lstStyle xmlns:a="http://schemas.openxmlformats.org/drawingml/2006/main"/>
           <a:p xmlns:a="http://schemas.openxmlformats.org/drawingml/2006/main">
             <a:pPr algn="ctr">
+              <a:buNone/>
               <a:defRPr sz="2100" b="1">
                 <a:solidFill>
                   <a:srgbClr val="213C33"/>
@@ -4403,6 +4420,7 @@
           <a:lstStyle xmlns:a="http://schemas.openxmlformats.org/drawingml/2006/main"/>
           <a:p xmlns:a="http://schemas.openxmlformats.org/drawingml/2006/main">
             <a:pPr algn="ctr">
+              <a:buNone/>
               <a:defRPr sz="1575" b="0">
                 <a:solidFill>
                   <a:srgbClr val="64766C"/>
@@ -4484,7 +4502,7 @@
       </p:sp>
       <p:cxnSp>
         <p:nvCxnSpPr>
-          <p:cNvPr id="60" name=""/>
+          <p:cNvPr id="102" name=""/>
           <p:cNvCxnSpPr>
             <a:stCxn xmlns:a="http://schemas.openxmlformats.org/drawingml/2006/main" id="12" idx="3"/>
             <a:endCxn xmlns:a="http://schemas.openxmlformats.org/drawingml/2006/main" id="13" idx="1"/>
@@ -4542,6 +4560,7 @@
           <a:lstStyle xmlns:a="http://schemas.openxmlformats.org/drawingml/2006/main"/>
           <a:p xmlns:a="http://schemas.openxmlformats.org/drawingml/2006/main">
             <a:pPr algn="ctr">
+              <a:buNone/>
               <a:defRPr sz="1800" b="1">
                 <a:solidFill>
                   <a:srgbClr val="72568B"/>
@@ -4599,6 +4618,7 @@
           <a:lstStyle xmlns:a="http://schemas.openxmlformats.org/drawingml/2006/main"/>
           <a:p xmlns:a="http://schemas.openxmlformats.org/drawingml/2006/main">
             <a:pPr algn="ctr">
+              <a:buNone/>
               <a:defRPr sz="1500" b="0">
                 <a:solidFill>
                   <a:srgbClr val="72568B"/>
@@ -4680,7 +4700,7 @@
       </p:sp>
       <p:cxnSp>
         <p:nvCxnSpPr>
-          <p:cNvPr id="65" name=""/>
+          <p:cNvPr id="107" name=""/>
           <p:cNvCxnSpPr>
             <a:stCxn xmlns:a="http://schemas.openxmlformats.org/drawingml/2006/main" id="17" idx="1"/>
             <a:endCxn xmlns:a="http://schemas.openxmlformats.org/drawingml/2006/main" id="18" idx="3"/>
@@ -4738,6 +4758,7 @@
           <a:lstStyle xmlns:a="http://schemas.openxmlformats.org/drawingml/2006/main"/>
           <a:p xmlns:a="http://schemas.openxmlformats.org/drawingml/2006/main">
             <a:pPr algn="ctr">
+              <a:buNone/>
               <a:defRPr sz="1800" b="1">
                 <a:solidFill>
                   <a:srgbClr val="72568B"/>
@@ -4795,6 +4816,7 @@
           <a:lstStyle xmlns:a="http://schemas.openxmlformats.org/drawingml/2006/main"/>
           <a:p xmlns:a="http://schemas.openxmlformats.org/drawingml/2006/main">
             <a:pPr algn="ctr">
+              <a:buNone/>
               <a:defRPr sz="1500" b="0">
                 <a:solidFill>
                   <a:srgbClr val="72568B"/>
@@ -4884,6 +4906,7 @@
           <a:lstStyle xmlns:a="http://schemas.openxmlformats.org/drawingml/2006/main"/>
           <a:p xmlns:a="http://schemas.openxmlformats.org/drawingml/2006/main">
             <a:pPr algn="ctr">
+              <a:buNone/>
               <a:defRPr sz="2400" b="1">
                 <a:solidFill>
                   <a:srgbClr val="FFFFFF"/>
@@ -4941,6 +4964,7 @@
           <a:lstStyle xmlns:a="http://schemas.openxmlformats.org/drawingml/2006/main"/>
           <a:p xmlns:a="http://schemas.openxmlformats.org/drawingml/2006/main">
             <a:pPr algn="ctr">
+              <a:buNone/>
               <a:defRPr sz="1650" b="0">
                 <a:solidFill>
                   <a:srgbClr val="D8E5D5"/>
@@ -5022,7 +5046,7 @@
       </p:sp>
       <p:cxnSp>
         <p:nvCxnSpPr>
-          <p:cNvPr id="73" name=""/>
+          <p:cNvPr id="115" name=""/>
           <p:cNvCxnSpPr>
             <a:stCxn xmlns:a="http://schemas.openxmlformats.org/drawingml/2006/main" id="25" idx="2"/>
             <a:endCxn xmlns:a="http://schemas.openxmlformats.org/drawingml/2006/main" id="26" idx="0"/>
@@ -5080,6 +5104,7 @@
           <a:lstStyle xmlns:a="http://schemas.openxmlformats.org/drawingml/2006/main"/>
           <a:p xmlns:a="http://schemas.openxmlformats.org/drawingml/2006/main">
             <a:pPr algn="l">
+              <a:buNone/>
               <a:defRPr sz="2025" b="1">
                 <a:solidFill>
                   <a:srgbClr val="2D6350"/>
@@ -5137,6 +5162,7 @@
           <a:lstStyle xmlns:a="http://schemas.openxmlformats.org/drawingml/2006/main"/>
           <a:p xmlns:a="http://schemas.openxmlformats.org/drawingml/2006/main">
             <a:pPr algn="l">
+              <a:buNone/>
               <a:defRPr sz="1725" b="0">
                 <a:solidFill>
                   <a:srgbClr val="2D6350"/>
@@ -5218,7 +5244,7 @@
       </p:sp>
       <p:cxnSp>
         <p:nvCxnSpPr>
-          <p:cNvPr id="78" name=""/>
+          <p:cNvPr id="120" name=""/>
           <p:cNvCxnSpPr>
             <a:stCxn xmlns:a="http://schemas.openxmlformats.org/drawingml/2006/main" id="30" idx="2"/>
             <a:endCxn xmlns:a="http://schemas.openxmlformats.org/drawingml/2006/main" id="31" idx="0"/>
@@ -5276,6 +5302,7 @@
           <a:lstStyle xmlns:a="http://schemas.openxmlformats.org/drawingml/2006/main"/>
           <a:p xmlns:a="http://schemas.openxmlformats.org/drawingml/2006/main">
             <a:pPr algn="l">
+              <a:buNone/>
               <a:defRPr sz="2025" b="1">
                 <a:solidFill>
                   <a:srgbClr val="2D6350"/>
@@ -5333,6 +5360,7 @@
           <a:lstStyle xmlns:a="http://schemas.openxmlformats.org/drawingml/2006/main"/>
           <a:p xmlns:a="http://schemas.openxmlformats.org/drawingml/2006/main">
             <a:pPr algn="l">
+              <a:buNone/>
               <a:defRPr sz="1725" b="0">
                 <a:solidFill>
                   <a:srgbClr val="2D6350"/>
@@ -5414,7 +5442,7 @@
       </p:sp>
       <p:cxnSp>
         <p:nvCxnSpPr>
-          <p:cNvPr id="83" name=""/>
+          <p:cNvPr id="125" name=""/>
           <p:cNvCxnSpPr>
             <a:stCxn xmlns:a="http://schemas.openxmlformats.org/drawingml/2006/main" id="35" idx="2"/>
             <a:endCxn xmlns:a="http://schemas.openxmlformats.org/drawingml/2006/main" id="36" idx="0"/>
@@ -5472,6 +5500,7 @@
           <a:lstStyle xmlns:a="http://schemas.openxmlformats.org/drawingml/2006/main"/>
           <a:p xmlns:a="http://schemas.openxmlformats.org/drawingml/2006/main">
             <a:pPr algn="l">
+              <a:buNone/>
               <a:defRPr sz="2025" b="1">
                 <a:solidFill>
                   <a:srgbClr val="2D6350"/>
@@ -5529,6 +5558,7 @@
           <a:lstStyle xmlns:a="http://schemas.openxmlformats.org/drawingml/2006/main"/>
           <a:p xmlns:a="http://schemas.openxmlformats.org/drawingml/2006/main">
             <a:pPr algn="l">
+              <a:buNone/>
               <a:defRPr sz="1575" b="0">
                 <a:solidFill>
                   <a:srgbClr val="2D6350"/>
@@ -5610,7 +5640,7 @@
       </p:sp>
       <p:cxnSp>
         <p:nvCxnSpPr>
-          <p:cNvPr id="88" name=""/>
+          <p:cNvPr id="130" name=""/>
           <p:cNvCxnSpPr>
             <a:stCxn xmlns:a="http://schemas.openxmlformats.org/drawingml/2006/main" id="40" idx="0"/>
             <a:endCxn xmlns:a="http://schemas.openxmlformats.org/drawingml/2006/main" id="41" idx="2"/>
@@ -5668,6 +5698,7 @@
           <a:lstStyle xmlns:a="http://schemas.openxmlformats.org/drawingml/2006/main"/>
           <a:p xmlns:a="http://schemas.openxmlformats.org/drawingml/2006/main">
             <a:pPr algn="l">
+              <a:buNone/>
               <a:defRPr sz="2025" b="1">
                 <a:solidFill>
                   <a:srgbClr val="356D93"/>
@@ -5725,6 +5756,7 @@
           <a:lstStyle xmlns:a="http://schemas.openxmlformats.org/drawingml/2006/main"/>
           <a:p xmlns:a="http://schemas.openxmlformats.org/drawingml/2006/main">
             <a:pPr algn="l">
+              <a:buNone/>
               <a:defRPr sz="1650" b="0">
                 <a:solidFill>
                   <a:srgbClr val="356D93"/>
@@ -5782,6 +5814,7 @@
           <a:lstStyle xmlns:a="http://schemas.openxmlformats.org/drawingml/2006/main"/>
           <a:p xmlns:a="http://schemas.openxmlformats.org/drawingml/2006/main">
             <a:pPr algn="l">
+              <a:buNone/>
               <a:defRPr sz="1725" b="1">
                 <a:solidFill>
                   <a:srgbClr val="213C33"/>
@@ -5839,6 +5872,7 @@
           <a:lstStyle xmlns:a="http://schemas.openxmlformats.org/drawingml/2006/main"/>
           <a:p xmlns:a="http://schemas.openxmlformats.org/drawingml/2006/main">
             <a:pPr algn="l">
+              <a:buNone/>
               <a:defRPr sz="1575" b="0">
                 <a:solidFill>
                   <a:srgbClr val="64766C"/>
@@ -6674,6 +6708,7 @@
           <a:lstStyle xmlns:a="http://schemas.openxmlformats.org/drawingml/2006/main"/>
           <a:p xmlns:a="http://schemas.openxmlformats.org/drawingml/2006/main">
             <a:pPr algn="l">
+              <a:buNone/>
               <a:defRPr sz="3300" b="1">
                 <a:solidFill>
                   <a:srgbClr val="213C33"/>
@@ -6731,6 +6766,7 @@
           <a:lstStyle xmlns:a="http://schemas.openxmlformats.org/drawingml/2006/main"/>
           <a:p xmlns:a="http://schemas.openxmlformats.org/drawingml/2006/main">
             <a:pPr algn="l">
+              <a:buNone/>
               <a:defRPr sz="2325" b="0">
                 <a:solidFill>
                   <a:srgbClr val="64766C"/>
@@ -6820,6 +6856,7 @@
           <a:lstStyle xmlns:a="http://schemas.openxmlformats.org/drawingml/2006/main"/>
           <a:p xmlns:a="http://schemas.openxmlformats.org/drawingml/2006/main">
             <a:pPr algn="ctr">
+              <a:buNone/>
               <a:defRPr sz="2100" b="1">
                 <a:solidFill>
                   <a:srgbClr val="213C33"/>
@@ -6877,6 +6914,7 @@
           <a:lstStyle xmlns:a="http://schemas.openxmlformats.org/drawingml/2006/main"/>
           <a:p xmlns:a="http://schemas.openxmlformats.org/drawingml/2006/main">
             <a:pPr algn="ctr">
+              <a:buNone/>
               <a:defRPr sz="1575" b="0">
                 <a:solidFill>
                   <a:srgbClr val="64766C"/>
@@ -6958,7 +6996,7 @@
       </p:sp>
       <p:cxnSp>
         <p:nvCxnSpPr>
-          <p:cNvPr id="45" name=""/>
+          <p:cNvPr id="78" name=""/>
           <p:cNvCxnSpPr>
             <a:stCxn xmlns:a="http://schemas.openxmlformats.org/drawingml/2006/main" id="6" idx="2"/>
             <a:endCxn xmlns:a="http://schemas.openxmlformats.org/drawingml/2006/main" id="7" idx="0"/>
@@ -7047,6 +7085,7 @@
           <a:lstStyle xmlns:a="http://schemas.openxmlformats.org/drawingml/2006/main"/>
           <a:p xmlns:a="http://schemas.openxmlformats.org/drawingml/2006/main">
             <a:pPr algn="ctr">
+              <a:buNone/>
               <a:defRPr sz="2100" b="1">
                 <a:solidFill>
                   <a:srgbClr val="213C33"/>
@@ -7104,6 +7143,7 @@
           <a:lstStyle xmlns:a="http://schemas.openxmlformats.org/drawingml/2006/main"/>
           <a:p xmlns:a="http://schemas.openxmlformats.org/drawingml/2006/main">
             <a:pPr algn="ctr">
+              <a:buNone/>
               <a:defRPr sz="1575" b="0">
                 <a:solidFill>
                   <a:srgbClr val="64766C"/>
@@ -7185,7 +7225,7 @@
       </p:sp>
       <p:cxnSp>
         <p:nvCxnSpPr>
-          <p:cNvPr id="51" name=""/>
+          <p:cNvPr id="84" name=""/>
           <p:cNvCxnSpPr>
             <a:stCxn xmlns:a="http://schemas.openxmlformats.org/drawingml/2006/main" id="12" idx="2"/>
             <a:endCxn xmlns:a="http://schemas.openxmlformats.org/drawingml/2006/main" id="13" idx="0"/>
@@ -7274,6 +7314,7 @@
           <a:lstStyle xmlns:a="http://schemas.openxmlformats.org/drawingml/2006/main"/>
           <a:p xmlns:a="http://schemas.openxmlformats.org/drawingml/2006/main">
             <a:pPr algn="ctr">
+              <a:buNone/>
               <a:defRPr sz="2100" b="1">
                 <a:solidFill>
                   <a:srgbClr val="213C33"/>
@@ -7331,6 +7372,7 @@
           <a:lstStyle xmlns:a="http://schemas.openxmlformats.org/drawingml/2006/main"/>
           <a:p xmlns:a="http://schemas.openxmlformats.org/drawingml/2006/main">
             <a:pPr algn="ctr">
+              <a:buNone/>
               <a:defRPr sz="1575" b="0">
                 <a:solidFill>
                   <a:srgbClr val="64766C"/>
@@ -7412,7 +7454,7 @@
       </p:sp>
       <p:cxnSp>
         <p:nvCxnSpPr>
-          <p:cNvPr id="57" name=""/>
+          <p:cNvPr id="90" name=""/>
           <p:cNvCxnSpPr>
             <a:stCxn xmlns:a="http://schemas.openxmlformats.org/drawingml/2006/main" id="18" idx="2"/>
             <a:endCxn xmlns:a="http://schemas.openxmlformats.org/drawingml/2006/main" id="19" idx="0"/>
@@ -7493,7 +7535,7 @@
       </p:sp>
       <p:cxnSp>
         <p:nvCxnSpPr>
-          <p:cNvPr id="60" name=""/>
+          <p:cNvPr id="93" name=""/>
           <p:cNvCxnSpPr>
             <a:stCxn xmlns:a="http://schemas.openxmlformats.org/drawingml/2006/main" id="21" idx="3"/>
             <a:endCxn xmlns:a="http://schemas.openxmlformats.org/drawingml/2006/main" id="22" idx="1"/>
@@ -7553,6 +7595,7 @@
           <a:lstStyle xmlns:a="http://schemas.openxmlformats.org/drawingml/2006/main"/>
           <a:p xmlns:a="http://schemas.openxmlformats.org/drawingml/2006/main">
             <a:pPr algn="ctr">
+              <a:buNone/>
               <a:defRPr sz="1950" b="1">
                 <a:solidFill>
                   <a:srgbClr val="72568B"/>
@@ -7612,6 +7655,7 @@
           <a:lstStyle xmlns:a="http://schemas.openxmlformats.org/drawingml/2006/main"/>
           <a:p xmlns:a="http://schemas.openxmlformats.org/drawingml/2006/main">
             <a:pPr algn="ctr">
+              <a:buNone/>
               <a:defRPr sz="1650" b="0">
                 <a:solidFill>
                   <a:srgbClr val="72568B"/>
@@ -7693,7 +7737,7 @@
       </p:sp>
       <p:cxnSp>
         <p:nvCxnSpPr>
-          <p:cNvPr id="65" name=""/>
+          <p:cNvPr id="98" name=""/>
           <p:cNvCxnSpPr>
             <a:stCxn xmlns:a="http://schemas.openxmlformats.org/drawingml/2006/main" id="26" idx="3"/>
             <a:endCxn xmlns:a="http://schemas.openxmlformats.org/drawingml/2006/main" id="27" idx="1"/>
@@ -7753,6 +7797,7 @@
           <a:lstStyle xmlns:a="http://schemas.openxmlformats.org/drawingml/2006/main"/>
           <a:p xmlns:a="http://schemas.openxmlformats.org/drawingml/2006/main">
             <a:pPr algn="ctr">
+              <a:buNone/>
               <a:defRPr sz="1950" b="1">
                 <a:solidFill>
                   <a:srgbClr val="2D6350"/>
@@ -7812,6 +7857,7 @@
           <a:lstStyle xmlns:a="http://schemas.openxmlformats.org/drawingml/2006/main"/>
           <a:p xmlns:a="http://schemas.openxmlformats.org/drawingml/2006/main">
             <a:pPr algn="ctr">
+              <a:buNone/>
               <a:defRPr sz="1650" b="0">
                 <a:solidFill>
                   <a:srgbClr val="2D6350"/>
@@ -7893,7 +7939,7 @@
       </p:sp>
       <p:cxnSp>
         <p:nvCxnSpPr>
-          <p:cNvPr id="70" name=""/>
+          <p:cNvPr id="103" name=""/>
           <p:cNvCxnSpPr>
             <a:stCxn xmlns:a="http://schemas.openxmlformats.org/drawingml/2006/main" id="31" idx="1"/>
             <a:endCxn xmlns:a="http://schemas.openxmlformats.org/drawingml/2006/main" id="32" idx="3"/>
@@ -7953,6 +7999,7 @@
           <a:lstStyle xmlns:a="http://schemas.openxmlformats.org/drawingml/2006/main"/>
           <a:p xmlns:a="http://schemas.openxmlformats.org/drawingml/2006/main">
             <a:pPr algn="ctr">
+              <a:buNone/>
               <a:defRPr sz="1950" b="1">
                 <a:solidFill>
                   <a:srgbClr val="72568B"/>
@@ -8012,6 +8059,7 @@
           <a:lstStyle xmlns:a="http://schemas.openxmlformats.org/drawingml/2006/main"/>
           <a:p xmlns:a="http://schemas.openxmlformats.org/drawingml/2006/main">
             <a:pPr algn="ctr">
+              <a:buNone/>
               <a:defRPr sz="1650" b="0">
                 <a:solidFill>
                   <a:srgbClr val="72568B"/>
@@ -8069,6 +8117,7 @@
           <a:lstStyle xmlns:a="http://schemas.openxmlformats.org/drawingml/2006/main"/>
           <a:p xmlns:a="http://schemas.openxmlformats.org/drawingml/2006/main">
             <a:pPr algn="l">
+              <a:buNone/>
               <a:defRPr sz="1725" b="1">
                 <a:solidFill>
                   <a:srgbClr val="213C33"/>
@@ -8126,6 +8175,7 @@
           <a:lstStyle xmlns:a="http://schemas.openxmlformats.org/drawingml/2006/main"/>
           <a:p xmlns:a="http://schemas.openxmlformats.org/drawingml/2006/main">
             <a:pPr algn="l">
+              <a:buNone/>
               <a:defRPr sz="1575" b="0">
                 <a:solidFill>
                   <a:srgbClr val="64766C"/>
@@ -8212,6 +8262,7 @@
           <a:lstStyle xmlns:a="http://schemas.openxmlformats.org/drawingml/2006/main"/>
           <a:p xmlns:a="http://schemas.openxmlformats.org/drawingml/2006/main">
             <a:pPr algn="l">
+              <a:buNone/>
               <a:defRPr sz="3300" b="1">
                 <a:solidFill>
                   <a:srgbClr val="213C33"/>
@@ -8269,6 +8320,7 @@
           <a:lstStyle xmlns:a="http://schemas.openxmlformats.org/drawingml/2006/main"/>
           <a:p xmlns:a="http://schemas.openxmlformats.org/drawingml/2006/main">
             <a:pPr algn="l">
+              <a:buNone/>
               <a:defRPr sz="2325" b="0">
                 <a:solidFill>
                   <a:srgbClr val="64766C"/>
@@ -8358,6 +8410,7 @@
           <a:lstStyle xmlns:a="http://schemas.openxmlformats.org/drawingml/2006/main"/>
           <a:p xmlns:a="http://schemas.openxmlformats.org/drawingml/2006/main">
             <a:pPr algn="ctr">
+              <a:buNone/>
               <a:defRPr sz="2100" b="1">
                 <a:solidFill>
                   <a:srgbClr val="213C33"/>
@@ -8415,6 +8468,7 @@
           <a:lstStyle xmlns:a="http://schemas.openxmlformats.org/drawingml/2006/main"/>
           <a:p xmlns:a="http://schemas.openxmlformats.org/drawingml/2006/main">
             <a:pPr algn="ctr">
+              <a:buNone/>
               <a:defRPr sz="1575" b="0">
                 <a:solidFill>
                   <a:srgbClr val="64766C"/>
@@ -8496,7 +8550,7 @@
       </p:sp>
       <p:cxnSp>
         <p:nvCxnSpPr>
-          <p:cNvPr id="45" name=""/>
+          <p:cNvPr id="78" name=""/>
           <p:cNvCxnSpPr>
             <a:stCxn xmlns:a="http://schemas.openxmlformats.org/drawingml/2006/main" id="6" idx="2"/>
             <a:endCxn xmlns:a="http://schemas.openxmlformats.org/drawingml/2006/main" id="7" idx="0"/>
@@ -8585,6 +8639,7 @@
           <a:lstStyle xmlns:a="http://schemas.openxmlformats.org/drawingml/2006/main"/>
           <a:p xmlns:a="http://schemas.openxmlformats.org/drawingml/2006/main">
             <a:pPr algn="ctr">
+              <a:buNone/>
               <a:defRPr sz="2100" b="1">
                 <a:solidFill>
                   <a:srgbClr val="213C33"/>
@@ -8642,6 +8697,7 @@
           <a:lstStyle xmlns:a="http://schemas.openxmlformats.org/drawingml/2006/main"/>
           <a:p xmlns:a="http://schemas.openxmlformats.org/drawingml/2006/main">
             <a:pPr algn="ctr">
+              <a:buNone/>
               <a:defRPr sz="1575" b="0">
                 <a:solidFill>
                   <a:srgbClr val="64766C"/>
@@ -8723,7 +8779,7 @@
       </p:sp>
       <p:cxnSp>
         <p:nvCxnSpPr>
-          <p:cNvPr id="51" name=""/>
+          <p:cNvPr id="84" name=""/>
           <p:cNvCxnSpPr>
             <a:stCxn xmlns:a="http://schemas.openxmlformats.org/drawingml/2006/main" id="12" idx="2"/>
             <a:endCxn xmlns:a="http://schemas.openxmlformats.org/drawingml/2006/main" id="13" idx="0"/>
@@ -8812,6 +8868,7 @@
           <a:lstStyle xmlns:a="http://schemas.openxmlformats.org/drawingml/2006/main"/>
           <a:p xmlns:a="http://schemas.openxmlformats.org/drawingml/2006/main">
             <a:pPr algn="ctr">
+              <a:buNone/>
               <a:defRPr sz="2100" b="1">
                 <a:solidFill>
                   <a:srgbClr val="213C33"/>
@@ -8869,6 +8926,7 @@
           <a:lstStyle xmlns:a="http://schemas.openxmlformats.org/drawingml/2006/main"/>
           <a:p xmlns:a="http://schemas.openxmlformats.org/drawingml/2006/main">
             <a:pPr algn="ctr">
+              <a:buNone/>
               <a:defRPr sz="1575" b="0">
                 <a:solidFill>
                   <a:srgbClr val="64766C"/>
@@ -8950,7 +9008,7 @@
       </p:sp>
       <p:cxnSp>
         <p:nvCxnSpPr>
-          <p:cNvPr id="57" name=""/>
+          <p:cNvPr id="90" name=""/>
           <p:cNvCxnSpPr>
             <a:stCxn xmlns:a="http://schemas.openxmlformats.org/drawingml/2006/main" id="18" idx="2"/>
             <a:endCxn xmlns:a="http://schemas.openxmlformats.org/drawingml/2006/main" id="19" idx="0"/>
@@ -9031,7 +9089,7 @@
       </p:sp>
       <p:cxnSp>
         <p:nvCxnSpPr>
-          <p:cNvPr id="60" name=""/>
+          <p:cNvPr id="93" name=""/>
           <p:cNvCxnSpPr>
             <a:stCxn xmlns:a="http://schemas.openxmlformats.org/drawingml/2006/main" id="21" idx="3"/>
             <a:endCxn xmlns:a="http://schemas.openxmlformats.org/drawingml/2006/main" id="22" idx="1"/>
@@ -9091,6 +9149,7 @@
           <a:lstStyle xmlns:a="http://schemas.openxmlformats.org/drawingml/2006/main"/>
           <a:p xmlns:a="http://schemas.openxmlformats.org/drawingml/2006/main">
             <a:pPr algn="ctr">
+              <a:buNone/>
               <a:defRPr sz="1950" b="1">
                 <a:solidFill>
                   <a:srgbClr val="72568B"/>
@@ -9150,6 +9209,7 @@
           <a:lstStyle xmlns:a="http://schemas.openxmlformats.org/drawingml/2006/main"/>
           <a:p xmlns:a="http://schemas.openxmlformats.org/drawingml/2006/main">
             <a:pPr algn="ctr">
+              <a:buNone/>
               <a:defRPr sz="1650" b="0">
                 <a:solidFill>
                   <a:srgbClr val="72568B"/>
@@ -9231,7 +9291,7 @@
       </p:sp>
       <p:cxnSp>
         <p:nvCxnSpPr>
-          <p:cNvPr id="65" name=""/>
+          <p:cNvPr id="98" name=""/>
           <p:cNvCxnSpPr>
             <a:stCxn xmlns:a="http://schemas.openxmlformats.org/drawingml/2006/main" id="26" idx="3"/>
             <a:endCxn xmlns:a="http://schemas.openxmlformats.org/drawingml/2006/main" id="27" idx="1"/>
@@ -9291,6 +9351,7 @@
           <a:lstStyle xmlns:a="http://schemas.openxmlformats.org/drawingml/2006/main"/>
           <a:p xmlns:a="http://schemas.openxmlformats.org/drawingml/2006/main">
             <a:pPr algn="ctr">
+              <a:buNone/>
               <a:defRPr sz="1950" b="1">
                 <a:solidFill>
                   <a:srgbClr val="2D6350"/>
@@ -9350,6 +9411,7 @@
           <a:lstStyle xmlns:a="http://schemas.openxmlformats.org/drawingml/2006/main"/>
           <a:p xmlns:a="http://schemas.openxmlformats.org/drawingml/2006/main">
             <a:pPr algn="ctr">
+              <a:buNone/>
               <a:defRPr sz="1650" b="0">
                 <a:solidFill>
                   <a:srgbClr val="2D6350"/>
@@ -9431,7 +9493,7 @@
       </p:sp>
       <p:cxnSp>
         <p:nvCxnSpPr>
-          <p:cNvPr id="70" name=""/>
+          <p:cNvPr id="103" name=""/>
           <p:cNvCxnSpPr>
             <a:stCxn xmlns:a="http://schemas.openxmlformats.org/drawingml/2006/main" id="31" idx="1"/>
             <a:endCxn xmlns:a="http://schemas.openxmlformats.org/drawingml/2006/main" id="32" idx="3"/>
@@ -9491,6 +9553,7 @@
           <a:lstStyle xmlns:a="http://schemas.openxmlformats.org/drawingml/2006/main"/>
           <a:p xmlns:a="http://schemas.openxmlformats.org/drawingml/2006/main">
             <a:pPr algn="ctr">
+              <a:buNone/>
               <a:defRPr sz="1950" b="1">
                 <a:solidFill>
                   <a:srgbClr val="72568B"/>
@@ -9550,6 +9613,7 @@
           <a:lstStyle xmlns:a="http://schemas.openxmlformats.org/drawingml/2006/main"/>
           <a:p xmlns:a="http://schemas.openxmlformats.org/drawingml/2006/main">
             <a:pPr algn="ctr">
+              <a:buNone/>
               <a:defRPr sz="1650" b="0">
                 <a:solidFill>
                   <a:srgbClr val="72568B"/>
@@ -9607,6 +9671,7 @@
           <a:lstStyle xmlns:a="http://schemas.openxmlformats.org/drawingml/2006/main"/>
           <a:p xmlns:a="http://schemas.openxmlformats.org/drawingml/2006/main">
             <a:pPr algn="l">
+              <a:buNone/>
               <a:defRPr sz="1725" b="1">
                 <a:solidFill>
                   <a:srgbClr val="213C33"/>
@@ -9664,6 +9729,7 @@
           <a:lstStyle xmlns:a="http://schemas.openxmlformats.org/drawingml/2006/main"/>
           <a:p xmlns:a="http://schemas.openxmlformats.org/drawingml/2006/main">
             <a:pPr algn="l">
+              <a:buNone/>
               <a:defRPr sz="1575" b="0">
                 <a:solidFill>
                   <a:srgbClr val="64766C"/>
@@ -9750,6 +9816,7 @@
           <a:lstStyle xmlns:a="http://schemas.openxmlformats.org/drawingml/2006/main"/>
           <a:p xmlns:a="http://schemas.openxmlformats.org/drawingml/2006/main">
             <a:pPr algn="l">
+              <a:buNone/>
               <a:defRPr sz="3300" b="1">
                 <a:solidFill>
                   <a:srgbClr val="213C33"/>
@@ -9807,6 +9874,7 @@
           <a:lstStyle xmlns:a="http://schemas.openxmlformats.org/drawingml/2006/main"/>
           <a:p xmlns:a="http://schemas.openxmlformats.org/drawingml/2006/main">
             <a:pPr algn="l">
+              <a:buNone/>
               <a:defRPr sz="2325" b="0">
                 <a:solidFill>
                   <a:srgbClr val="64766C"/>
@@ -9896,6 +9964,7 @@
           <a:lstStyle xmlns:a="http://schemas.openxmlformats.org/drawingml/2006/main"/>
           <a:p xmlns:a="http://schemas.openxmlformats.org/drawingml/2006/main">
             <a:pPr algn="ctr">
+              <a:buNone/>
               <a:defRPr sz="2100" b="1">
                 <a:solidFill>
                   <a:srgbClr val="213C33"/>
@@ -9953,6 +10022,7 @@
           <a:lstStyle xmlns:a="http://schemas.openxmlformats.org/drawingml/2006/main"/>
           <a:p xmlns:a="http://schemas.openxmlformats.org/drawingml/2006/main">
             <a:pPr algn="ctr">
+              <a:buNone/>
               <a:defRPr sz="1575" b="0">
                 <a:solidFill>
                   <a:srgbClr val="64766C"/>
@@ -10034,7 +10104,7 @@
       </p:sp>
       <p:cxnSp>
         <p:nvCxnSpPr>
-          <p:cNvPr id="45" name=""/>
+          <p:cNvPr id="78" name=""/>
           <p:cNvCxnSpPr>
             <a:stCxn xmlns:a="http://schemas.openxmlformats.org/drawingml/2006/main" id="6" idx="2"/>
             <a:endCxn xmlns:a="http://schemas.openxmlformats.org/drawingml/2006/main" id="7" idx="0"/>
@@ -10123,6 +10193,7 @@
           <a:lstStyle xmlns:a="http://schemas.openxmlformats.org/drawingml/2006/main"/>
           <a:p xmlns:a="http://schemas.openxmlformats.org/drawingml/2006/main">
             <a:pPr algn="ctr">
+              <a:buNone/>
               <a:defRPr sz="2100" b="1">
                 <a:solidFill>
                   <a:srgbClr val="213C33"/>
@@ -10180,6 +10251,7 @@
           <a:lstStyle xmlns:a="http://schemas.openxmlformats.org/drawingml/2006/main"/>
           <a:p xmlns:a="http://schemas.openxmlformats.org/drawingml/2006/main">
             <a:pPr algn="ctr">
+              <a:buNone/>
               <a:defRPr sz="1575" b="0">
                 <a:solidFill>
                   <a:srgbClr val="64766C"/>
@@ -10261,7 +10333,7 @@
       </p:sp>
       <p:cxnSp>
         <p:nvCxnSpPr>
-          <p:cNvPr id="51" name=""/>
+          <p:cNvPr id="84" name=""/>
           <p:cNvCxnSpPr>
             <a:stCxn xmlns:a="http://schemas.openxmlformats.org/drawingml/2006/main" id="12" idx="2"/>
             <a:endCxn xmlns:a="http://schemas.openxmlformats.org/drawingml/2006/main" id="13" idx="0"/>
@@ -10350,6 +10422,7 @@
           <a:lstStyle xmlns:a="http://schemas.openxmlformats.org/drawingml/2006/main"/>
           <a:p xmlns:a="http://schemas.openxmlformats.org/drawingml/2006/main">
             <a:pPr algn="ctr">
+              <a:buNone/>
               <a:defRPr sz="2100" b="1">
                 <a:solidFill>
                   <a:srgbClr val="213C33"/>
@@ -10407,6 +10480,7 @@
           <a:lstStyle xmlns:a="http://schemas.openxmlformats.org/drawingml/2006/main"/>
           <a:p xmlns:a="http://schemas.openxmlformats.org/drawingml/2006/main">
             <a:pPr algn="ctr">
+              <a:buNone/>
               <a:defRPr sz="1575" b="0">
                 <a:solidFill>
                   <a:srgbClr val="64766C"/>
@@ -10488,7 +10562,7 @@
       </p:sp>
       <p:cxnSp>
         <p:nvCxnSpPr>
-          <p:cNvPr id="57" name=""/>
+          <p:cNvPr id="90" name=""/>
           <p:cNvCxnSpPr>
             <a:stCxn xmlns:a="http://schemas.openxmlformats.org/drawingml/2006/main" id="18" idx="2"/>
             <a:endCxn xmlns:a="http://schemas.openxmlformats.org/drawingml/2006/main" id="19" idx="0"/>
@@ -10569,7 +10643,7 @@
       </p:sp>
       <p:cxnSp>
         <p:nvCxnSpPr>
-          <p:cNvPr id="60" name=""/>
+          <p:cNvPr id="93" name=""/>
           <p:cNvCxnSpPr>
             <a:stCxn xmlns:a="http://schemas.openxmlformats.org/drawingml/2006/main" id="21" idx="3"/>
             <a:endCxn xmlns:a="http://schemas.openxmlformats.org/drawingml/2006/main" id="22" idx="1"/>
@@ -10629,6 +10703,7 @@
           <a:lstStyle xmlns:a="http://schemas.openxmlformats.org/drawingml/2006/main"/>
           <a:p xmlns:a="http://schemas.openxmlformats.org/drawingml/2006/main">
             <a:pPr algn="ctr">
+              <a:buNone/>
               <a:defRPr sz="1950" b="1">
                 <a:solidFill>
                   <a:srgbClr val="72568B"/>
@@ -10688,6 +10763,7 @@
           <a:lstStyle xmlns:a="http://schemas.openxmlformats.org/drawingml/2006/main"/>
           <a:p xmlns:a="http://schemas.openxmlformats.org/drawingml/2006/main">
             <a:pPr algn="ctr">
+              <a:buNone/>
               <a:defRPr sz="1650" b="0">
                 <a:solidFill>
                   <a:srgbClr val="72568B"/>
@@ -10769,7 +10845,7 @@
       </p:sp>
       <p:cxnSp>
         <p:nvCxnSpPr>
-          <p:cNvPr id="65" name=""/>
+          <p:cNvPr id="98" name=""/>
           <p:cNvCxnSpPr>
             <a:stCxn xmlns:a="http://schemas.openxmlformats.org/drawingml/2006/main" id="26" idx="1"/>
             <a:endCxn xmlns:a="http://schemas.openxmlformats.org/drawingml/2006/main" id="27" idx="3"/>
@@ -10829,6 +10905,7 @@
           <a:lstStyle xmlns:a="http://schemas.openxmlformats.org/drawingml/2006/main"/>
           <a:p xmlns:a="http://schemas.openxmlformats.org/drawingml/2006/main">
             <a:pPr algn="ctr">
+              <a:buNone/>
               <a:defRPr sz="1950" b="1">
                 <a:solidFill>
                   <a:srgbClr val="72568B"/>
@@ -10888,6 +10965,7 @@
           <a:lstStyle xmlns:a="http://schemas.openxmlformats.org/drawingml/2006/main"/>
           <a:p xmlns:a="http://schemas.openxmlformats.org/drawingml/2006/main">
             <a:pPr algn="ctr">
+              <a:buNone/>
               <a:defRPr sz="1650" b="0">
                 <a:solidFill>
                   <a:srgbClr val="72568B"/>
@@ -10969,7 +11047,7 @@
       </p:sp>
       <p:cxnSp>
         <p:nvCxnSpPr>
-          <p:cNvPr id="70" name=""/>
+          <p:cNvPr id="103" name=""/>
           <p:cNvCxnSpPr>
             <a:stCxn xmlns:a="http://schemas.openxmlformats.org/drawingml/2006/main" id="31" idx="3"/>
             <a:endCxn xmlns:a="http://schemas.openxmlformats.org/drawingml/2006/main" id="32" idx="1"/>
@@ -11029,6 +11107,7 @@
           <a:lstStyle xmlns:a="http://schemas.openxmlformats.org/drawingml/2006/main"/>
           <a:p xmlns:a="http://schemas.openxmlformats.org/drawingml/2006/main">
             <a:pPr algn="ctr">
+              <a:buNone/>
               <a:defRPr sz="1950" b="1">
                 <a:solidFill>
                   <a:srgbClr val="2D6350"/>
@@ -11088,6 +11167,7 @@
           <a:lstStyle xmlns:a="http://schemas.openxmlformats.org/drawingml/2006/main"/>
           <a:p xmlns:a="http://schemas.openxmlformats.org/drawingml/2006/main">
             <a:pPr algn="ctr">
+              <a:buNone/>
               <a:defRPr sz="1650" b="0">
                 <a:solidFill>
                   <a:srgbClr val="2D6350"/>
@@ -11145,6 +11225,7 @@
           <a:lstStyle xmlns:a="http://schemas.openxmlformats.org/drawingml/2006/main"/>
           <a:p xmlns:a="http://schemas.openxmlformats.org/drawingml/2006/main">
             <a:pPr algn="l">
+              <a:buNone/>
               <a:defRPr sz="1725" b="1">
                 <a:solidFill>
                   <a:srgbClr val="213C33"/>
@@ -11202,6 +11283,7 @@
           <a:lstStyle xmlns:a="http://schemas.openxmlformats.org/drawingml/2006/main"/>
           <a:p xmlns:a="http://schemas.openxmlformats.org/drawingml/2006/main">
             <a:pPr algn="l">
+              <a:buNone/>
               <a:defRPr sz="1575" b="0">
                 <a:solidFill>
                   <a:srgbClr val="64766C"/>
@@ -11288,6 +11370,7 @@
           <a:lstStyle xmlns:a="http://schemas.openxmlformats.org/drawingml/2006/main"/>
           <a:p xmlns:a="http://schemas.openxmlformats.org/drawingml/2006/main">
             <a:pPr algn="l">
+              <a:buNone/>
               <a:defRPr sz="3300" b="1">
                 <a:solidFill>
                   <a:srgbClr val="213C33"/>
@@ -11306,7 +11389,7 @@
                 <a:ea typeface="Apple SD Gothic Neo"/>
                 <a:cs typeface="Apple SD Gothic Neo"/>
               </a:rPr>
-              <a:t>4. 업체와 심사위원의 독립 조회</a:t>
+              <a:t>4. 지갑 없이 공개 기록 조회</a:t>
             </a:r>
           </a:p>
         </p:txBody>
@@ -11345,6 +11428,7 @@
           <a:lstStyle xmlns:a="http://schemas.openxmlformats.org/drawingml/2006/main"/>
           <a:p xmlns:a="http://schemas.openxmlformats.org/drawingml/2006/main">
             <a:pPr algn="l">
+              <a:buNone/>
               <a:defRPr sz="2325" b="0">
                 <a:solidFill>
                   <a:srgbClr val="64766C"/>
@@ -11363,7 +11447,7 @@
                 <a:ea typeface="Apple SD Gothic Neo"/>
                 <a:cs typeface="Apple SD Gothic Neo"/>
               </a:rPr>
-              <a:t>Independent public verification</a:t>
+              <a:t>Public reads without a wallet</a:t>
             </a:r>
           </a:p>
         </p:txBody>
@@ -11434,6 +11518,7 @@
           <a:lstStyle xmlns:a="http://schemas.openxmlformats.org/drawingml/2006/main"/>
           <a:p xmlns:a="http://schemas.openxmlformats.org/drawingml/2006/main">
             <a:pPr algn="ctr">
+              <a:buNone/>
               <a:defRPr sz="2100" b="1">
                 <a:solidFill>
                   <a:srgbClr val="213C33"/>
@@ -11491,6 +11576,7 @@
           <a:lstStyle xmlns:a="http://schemas.openxmlformats.org/drawingml/2006/main"/>
           <a:p xmlns:a="http://schemas.openxmlformats.org/drawingml/2006/main">
             <a:pPr algn="ctr">
+              <a:buNone/>
               <a:defRPr sz="1575" b="0">
                 <a:solidFill>
                   <a:srgbClr val="64766C"/>
@@ -11572,7 +11658,7 @@
       </p:sp>
       <p:cxnSp>
         <p:nvCxnSpPr>
-          <p:cNvPr id="45" name=""/>
+          <p:cNvPr id="78" name=""/>
           <p:cNvCxnSpPr>
             <a:stCxn xmlns:a="http://schemas.openxmlformats.org/drawingml/2006/main" id="6" idx="2"/>
             <a:endCxn xmlns:a="http://schemas.openxmlformats.org/drawingml/2006/main" id="7" idx="0"/>
@@ -11661,6 +11747,7 @@
           <a:lstStyle xmlns:a="http://schemas.openxmlformats.org/drawingml/2006/main"/>
           <a:p xmlns:a="http://schemas.openxmlformats.org/drawingml/2006/main">
             <a:pPr algn="ctr">
+              <a:buNone/>
               <a:defRPr sz="2100" b="1">
                 <a:solidFill>
                   <a:srgbClr val="213C33"/>
@@ -11679,7 +11766,7 @@
                 <a:ea typeface="Apple SD Gothic Neo"/>
                 <a:cs typeface="Apple SD Gothic Neo"/>
               </a:rPr>
-              <a:t>공개 인덱서</a:t>
+              <a:t>체인 밖 조회 서버</a:t>
             </a:r>
           </a:p>
         </p:txBody>
@@ -11718,6 +11805,7 @@
           <a:lstStyle xmlns:a="http://schemas.openxmlformats.org/drawingml/2006/main"/>
           <a:p xmlns:a="http://schemas.openxmlformats.org/drawingml/2006/main">
             <a:pPr algn="ctr">
+              <a:buNone/>
               <a:defRPr sz="1575" b="0">
                 <a:solidFill>
                   <a:srgbClr val="64766C"/>
@@ -11736,7 +11824,7 @@
                 <a:ea typeface="Apple SD Gothic Neo"/>
                 <a:cs typeface="Apple SD Gothic Neo"/>
               </a:rPr>
-              <a:t>Public indexer</a:t>
+              <a:t>Indexer (off-chain)</a:t>
             </a:r>
           </a:p>
         </p:txBody>
@@ -11799,7 +11887,7 @@
       </p:sp>
       <p:cxnSp>
         <p:nvCxnSpPr>
-          <p:cNvPr id="51" name=""/>
+          <p:cNvPr id="84" name=""/>
           <p:cNvCxnSpPr>
             <a:stCxn xmlns:a="http://schemas.openxmlformats.org/drawingml/2006/main" id="12" idx="2"/>
             <a:endCxn xmlns:a="http://schemas.openxmlformats.org/drawingml/2006/main" id="13" idx="0"/>
@@ -11888,6 +11976,7 @@
           <a:lstStyle xmlns:a="http://schemas.openxmlformats.org/drawingml/2006/main"/>
           <a:p xmlns:a="http://schemas.openxmlformats.org/drawingml/2006/main">
             <a:pPr algn="ctr">
+              <a:buNone/>
               <a:defRPr sz="2100" b="1">
                 <a:solidFill>
                   <a:srgbClr val="213C33"/>
@@ -11945,6 +12034,7 @@
           <a:lstStyle xmlns:a="http://schemas.openxmlformats.org/drawingml/2006/main"/>
           <a:p xmlns:a="http://schemas.openxmlformats.org/drawingml/2006/main">
             <a:pPr algn="ctr">
+              <a:buNone/>
               <a:defRPr sz="1575" b="0">
                 <a:solidFill>
                   <a:srgbClr val="64766C"/>
@@ -11963,7 +12053,7 @@
                 <a:ea typeface="Apple SD Gothic Neo"/>
                 <a:cs typeface="Apple SD Gothic Neo"/>
               </a:rPr>
-              <a:t>Local Devnet</a:t>
+              <a:t>Devnet (on-chain)</a:t>
             </a:r>
           </a:p>
         </p:txBody>
@@ -12026,7 +12116,7 @@
       </p:sp>
       <p:cxnSp>
         <p:nvCxnSpPr>
-          <p:cNvPr id="57" name=""/>
+          <p:cNvPr id="90" name=""/>
           <p:cNvCxnSpPr>
             <a:stCxn xmlns:a="http://schemas.openxmlformats.org/drawingml/2006/main" id="18" idx="2"/>
             <a:endCxn xmlns:a="http://schemas.openxmlformats.org/drawingml/2006/main" id="19" idx="0"/>
@@ -12107,7 +12197,7 @@
       </p:sp>
       <p:cxnSp>
         <p:nvCxnSpPr>
-          <p:cNvPr id="60" name=""/>
+          <p:cNvPr id="93" name=""/>
           <p:cNvCxnSpPr>
             <a:stCxn xmlns:a="http://schemas.openxmlformats.org/drawingml/2006/main" id="21" idx="1"/>
             <a:endCxn xmlns:a="http://schemas.openxmlformats.org/drawingml/2006/main" id="22" idx="3"/>
@@ -12167,6 +12257,7 @@
           <a:lstStyle xmlns:a="http://schemas.openxmlformats.org/drawingml/2006/main"/>
           <a:p xmlns:a="http://schemas.openxmlformats.org/drawingml/2006/main">
             <a:pPr algn="ctr">
+              <a:buNone/>
               <a:defRPr sz="1950" b="1">
                 <a:solidFill>
                   <a:srgbClr val="356D93"/>
@@ -12226,6 +12317,7 @@
           <a:lstStyle xmlns:a="http://schemas.openxmlformats.org/drawingml/2006/main"/>
           <a:p xmlns:a="http://schemas.openxmlformats.org/drawingml/2006/main">
             <a:pPr algn="ctr">
+              <a:buNone/>
               <a:defRPr sz="1650" b="0">
                 <a:solidFill>
                   <a:srgbClr val="356D93"/>
@@ -12307,7 +12399,7 @@
       </p:sp>
       <p:cxnSp>
         <p:nvCxnSpPr>
-          <p:cNvPr id="65" name=""/>
+          <p:cNvPr id="98" name=""/>
           <p:cNvCxnSpPr>
             <a:stCxn xmlns:a="http://schemas.openxmlformats.org/drawingml/2006/main" id="26" idx="3"/>
             <a:endCxn xmlns:a="http://schemas.openxmlformats.org/drawingml/2006/main" id="27" idx="1"/>
@@ -12367,6 +12459,7 @@
           <a:lstStyle xmlns:a="http://schemas.openxmlformats.org/drawingml/2006/main"/>
           <a:p xmlns:a="http://schemas.openxmlformats.org/drawingml/2006/main">
             <a:pPr algn="ctr">
+              <a:buNone/>
               <a:defRPr sz="1950" b="1">
                 <a:solidFill>
                   <a:srgbClr val="356D93"/>
@@ -12426,6 +12519,7 @@
           <a:lstStyle xmlns:a="http://schemas.openxmlformats.org/drawingml/2006/main"/>
           <a:p xmlns:a="http://schemas.openxmlformats.org/drawingml/2006/main">
             <a:pPr algn="ctr">
+              <a:buNone/>
               <a:defRPr sz="1650" b="0">
                 <a:solidFill>
                   <a:srgbClr val="356D93"/>
@@ -12507,7 +12601,7 @@
       </p:sp>
       <p:cxnSp>
         <p:nvCxnSpPr>
-          <p:cNvPr id="70" name=""/>
+          <p:cNvPr id="103" name=""/>
           <p:cNvCxnSpPr>
             <a:stCxn xmlns:a="http://schemas.openxmlformats.org/drawingml/2006/main" id="31" idx="1"/>
             <a:endCxn xmlns:a="http://schemas.openxmlformats.org/drawingml/2006/main" id="32" idx="3"/>
@@ -12567,6 +12661,7 @@
           <a:lstStyle xmlns:a="http://schemas.openxmlformats.org/drawingml/2006/main"/>
           <a:p xmlns:a="http://schemas.openxmlformats.org/drawingml/2006/main">
             <a:pPr algn="ctr">
+              <a:buNone/>
               <a:defRPr sz="1950" b="1">
                 <a:solidFill>
                   <a:srgbClr val="356D93"/>
@@ -12626,6 +12721,7 @@
           <a:lstStyle xmlns:a="http://schemas.openxmlformats.org/drawingml/2006/main"/>
           <a:p xmlns:a="http://schemas.openxmlformats.org/drawingml/2006/main">
             <a:pPr algn="ctr">
+              <a:buNone/>
               <a:defRPr sz="1650" b="0">
                 <a:solidFill>
                   <a:srgbClr val="356D93"/>
@@ -12683,6 +12779,7 @@
           <a:lstStyle xmlns:a="http://schemas.openxmlformats.org/drawingml/2006/main"/>
           <a:p xmlns:a="http://schemas.openxmlformats.org/drawingml/2006/main">
             <a:pPr algn="l">
+              <a:buNone/>
               <a:defRPr sz="1725" b="1">
                 <a:solidFill>
                   <a:srgbClr val="213C33"/>
@@ -12740,6 +12837,7 @@
           <a:lstStyle xmlns:a="http://schemas.openxmlformats.org/drawingml/2006/main"/>
           <a:p xmlns:a="http://schemas.openxmlformats.org/drawingml/2006/main">
             <a:pPr algn="l">
+              <a:buNone/>
               <a:defRPr sz="1575" b="0">
                 <a:solidFill>
                   <a:srgbClr val="64766C"/>
@@ -12917,7 +13015,7 @@
           <p:nvPr/>
         </p:nvPicPr>
         <p:blipFill>
-          <a:blip xmlns:r="http://schemas.openxmlformats.org/officeDocument/2006/relationships" xmlns:a="http://schemas.openxmlformats.org/drawingml/2006/main" r:embed="Rfc6082e64c014890"/>
+          <a:blip xmlns:r="http://schemas.openxmlformats.org/officeDocument/2006/relationships" xmlns:a="http://schemas.openxmlformats.org/drawingml/2006/main" r:embed="R7f31367c6e834846"/>
           <a:stretch xmlns:a="http://schemas.openxmlformats.org/drawingml/2006/main"/>
         </p:blipFill>
         <p:spPr>

</xml_diff>